<commit_message>
Strip the integration slide's bare '12' page marker at extraction
Its page number is a lone "12", which the NN / NN fixup cannot match — and a
generic bare-number strip would also delete legitimate design numerals (the
defect_generator's 01/02/03 step markers and 12.4x stat). Targeted fixup on
exactly that box; skeletons regenerated. Verified the integration slide in
the built deck now leads with its real headline.

Co-Authored-By: Claude Fable 5 <noreply@anthropic.com>
</commit_message>
<xml_diff>
--- a/skills/overview-deck/assets/skeletons/integration.pptx
+++ b/skills/overview-deck/assets/skeletons/integration.pptx
@@ -15229,72 +15229,6 @@
       </p:grpSpPr>
       <p:sp>
         <p:nvSpPr>
-          <p:cNvPr id="483" name="Google Shape;483;p58"/>
-          <p:cNvSpPr/>
-          <p:nvPr/>
-        </p:nvSpPr>
-        <p:spPr>
-          <a:xfrm>
-            <a:off x="10817081" y="6446359"/>
-            <a:ext cx="914377" cy="274313"/>
-          </a:xfrm>
-          <a:prstGeom prst="rect">
-            <a:avLst/>
-          </a:prstGeom>
-          <a:noFill/>
-          <a:ln>
-            <a:noFill/>
-          </a:ln>
-        </p:spPr>
-        <p:txBody>
-          <a:bodyPr anchorCtr="0" anchor="ctr" bIns="60932" lIns="121897" spcFirstLastPara="1" rIns="121897" wrap="square" tIns="60932">
-            <a:noAutofit/>
-          </a:bodyPr>
-          <a:lstStyle/>
-          <a:p>
-            <a:pPr indent="0" lvl="0" marL="0" marR="0" rtl="0" algn="r">
-              <a:lnSpc>
-                <a:spcPct val="100000"/>
-              </a:lnSpc>
-              <a:spcBef>
-                <a:spcPts val="0"/>
-              </a:spcBef>
-              <a:spcAft>
-                <a:spcPts val="0"/>
-              </a:spcAft>
-              <a:buClr>
-                <a:srgbClr val="8A8895"/>
-              </a:buClr>
-              <a:buSzPts val="900"/>
-              <a:buFont typeface="Proxima Nova"/>
-              <a:buNone/>
-            </a:pPr>
-            <a:r>
-              <a:rPr b="0" i="0" lang="en" sz="900" u="none" cap="none" strike="noStrike">
-                <a:solidFill>
-                  <a:srgbClr val="8A8895"/>
-                </a:solidFill>
-                <a:latin typeface="Proxima Nova"/>
-                <a:ea typeface="Proxima Nova"/>
-                <a:cs typeface="Proxima Nova"/>
-                <a:sym typeface="Proxima Nova"/>
-              </a:rPr>
-              <a:t>12</a:t>
-            </a:r>
-            <a:endParaRPr b="0" i="0" sz="900" u="none" cap="none" strike="noStrike">
-              <a:solidFill>
-                <a:srgbClr val="C0504D"/>
-              </a:solidFill>
-              <a:latin typeface="Calibri"/>
-              <a:ea typeface="Calibri"/>
-              <a:cs typeface="Calibri"/>
-              <a:sym typeface="Calibri"/>
-            </a:endParaRPr>
-          </a:p>
-        </p:txBody>
-      </p:sp>
-      <p:sp>
-        <p:nvSpPr>
           <p:cNvPr id="484" name="Google Shape;484;p58"/>
           <p:cNvSpPr/>
           <p:nvPr/>

</xml_diff>